<commit_message>
Add subjective condition data for all 4 conditions
The updated for_AI_.xlsx now includes satiety/headache/nausea/appetite
survey data for the solid and smoothie conditions (previously only the
onigiri+smoothie condition had this). Updates the report, artifact, and
slide deck to compare condition data across all 4 conditions instead of
just one, and notes that headache/nausea are uniformly minimal while
satiety/appetite differences track meal volume (onigiri included or not)
rather than food form.

Co-Authored-By: Claude Sonnet 5 <noreply@anthropic.com>
Claude-Session: https://claude.ai/code/session_01DcRcUoxisdbGwDrjp2AqNE
</commit_message>
<xml_diff>
--- a/analysis/slides/血糖値比較分析.pptx
+++ b/analysis/slides/血糖値比較分析.pptx
@@ -2140,7 +2140,7 @@
               <c:strCache>
                 <c:ptCount val="1"/>
                 <c:pt idx="0">
-                  <c:v>満腹感 (0-10)</c:v>
+                  <c:v>固形</c:v>
                 </c:pt>
               </c:strCache>
             </c:strRef>
@@ -2149,7 +2149,7 @@
             <a:solidFill>
               <a:srgbClr val="2A78D6"/>
             </a:solidFill>
-            <a:ln w="31750" cap="flat">
+            <a:ln w="25400" cap="flat">
               <a:solidFill>
                 <a:srgbClr val="2A78D6"/>
               </a:solidFill>
@@ -2185,7 +2185,7 @@
           </c:dLbls>
           <c:marker>
             <c:symbol val="circle"/>
-            <c:size val="6"/>
+            <c:size val="5"/>
             <c:spPr>
               <a:solidFill>
                 <a:srgbClr val="2A78D6"/>
@@ -2232,19 +2232,19 @@
                 <c:formatCode>General</c:formatCode>
                 <c:ptCount val="5"/>
                 <c:pt idx="0">
-                  <c:v>2.33</c:v>
+                  <c:v>1.67</c:v>
                 </c:pt>
                 <c:pt idx="1">
-                  <c:v>7.67</c:v>
+                  <c:v>4</c:v>
                 </c:pt>
                 <c:pt idx="2">
-                  <c:v>5.33</c:v>
+                  <c:v>4</c:v>
                 </c:pt>
                 <c:pt idx="3">
-                  <c:v>5.5</c:v>
+                  <c:v>2</c:v>
                 </c:pt>
                 <c:pt idx="4">
-                  <c:v>3.33</c:v>
+                  <c:v>2</c:v>
                 </c:pt>
               </c:numCache>
             </c:numRef>
@@ -2260,18 +2260,18 @@
               <c:strCache>
                 <c:ptCount val="1"/>
                 <c:pt idx="0">
-                  <c:v>吐き気 (1-5)</c:v>
+                  <c:v>スムージー</c:v>
                 </c:pt>
               </c:strCache>
             </c:strRef>
           </c:tx>
           <c:spPr>
             <a:solidFill>
-              <a:srgbClr val="E34948"/>
+              <a:srgbClr val="EB6834"/>
             </a:solidFill>
-            <a:ln w="31750" cap="flat">
+            <a:ln w="25400" cap="flat">
               <a:solidFill>
-                <a:srgbClr val="E34948"/>
+                <a:srgbClr val="EB6834"/>
               </a:solidFill>
               <a:prstDash val="solid"/>
               <a:round/>
@@ -2305,14 +2305,14 @@
           </c:dLbls>
           <c:marker>
             <c:symbol val="circle"/>
-            <c:size val="6"/>
+            <c:size val="5"/>
             <c:spPr>
               <a:solidFill>
-                <a:srgbClr val="E34948"/>
+                <a:srgbClr val="EB6834"/>
               </a:solidFill>
               <a:ln w="9525" cap="flat">
                 <a:solidFill>
-                  <a:srgbClr val="E34948"/>
+                  <a:srgbClr val="EB6834"/>
                 </a:solidFill>
                 <a:prstDash val="solid"/>
                 <a:round/>
@@ -2352,19 +2352,19 @@
                 <c:formatCode>General</c:formatCode>
                 <c:ptCount val="5"/>
                 <c:pt idx="0">
-                  <c:v>1</c:v>
+                  <c:v>3.33</c:v>
                 </c:pt>
                 <c:pt idx="1">
-                  <c:v>1</c:v>
+                  <c:v>3.67</c:v>
                 </c:pt>
                 <c:pt idx="2">
-                  <c:v>1</c:v>
+                  <c:v>5</c:v>
                 </c:pt>
                 <c:pt idx="3">
                   <c:v>2</c:v>
                 </c:pt>
                 <c:pt idx="4">
-                  <c:v>1</c:v>
+                  <c:v>1.33</c:v>
                 </c:pt>
               </c:numCache>
             </c:numRef>
@@ -2380,7 +2380,7 @@
               <c:strCache>
                 <c:ptCount val="1"/>
                 <c:pt idx="0">
-                  <c:v>食欲 (0-10)</c:v>
+                  <c:v>おにぎり+スムージー</c:v>
                 </c:pt>
               </c:strCache>
             </c:strRef>
@@ -2389,7 +2389,7 @@
             <a:solidFill>
               <a:srgbClr val="1BAF7A"/>
             </a:solidFill>
-            <a:ln w="31750" cap="flat">
+            <a:ln w="25400" cap="flat">
               <a:solidFill>
                 <a:srgbClr val="1BAF7A"/>
               </a:solidFill>
@@ -2425,7 +2425,7 @@
           </c:dLbls>
           <c:marker>
             <c:symbol val="circle"/>
-            <c:size val="6"/>
+            <c:size val="5"/>
             <c:spPr>
               <a:solidFill>
                 <a:srgbClr val="1BAF7A"/>
@@ -2472,10 +2472,10 @@
                 <c:formatCode>General</c:formatCode>
                 <c:ptCount val="5"/>
                 <c:pt idx="0">
-                  <c:v>7</c:v>
+                  <c:v>2.33</c:v>
                 </c:pt>
                 <c:pt idx="1">
-                  <c:v>3.67</c:v>
+                  <c:v>7.67</c:v>
                 </c:pt>
                 <c:pt idx="2">
                   <c:v>5.33</c:v>
@@ -2484,7 +2484,127 @@
                   <c:v>5.5</c:v>
                 </c:pt>
                 <c:pt idx="4">
-                  <c:v>5.67</c:v>
+                  <c:v>3.33</c:v>
+                </c:pt>
+              </c:numCache>
+            </c:numRef>
+          </c:val>
+          <c:smooth val="0"/>
+        </c:ser>
+        <c:ser>
+          <c:idx val="3"/>
+          <c:order val="3"/>
+          <c:tx>
+            <c:strRef>
+              <c:f>Sheet1!$E$1</c:f>
+              <c:strCache>
+                <c:ptCount val="1"/>
+                <c:pt idx="0">
+                  <c:v>おにぎり+糖質減</c:v>
+                </c:pt>
+              </c:strCache>
+            </c:strRef>
+          </c:tx>
+          <c:spPr>
+            <a:solidFill>
+              <a:srgbClr val="EDA100"/>
+            </a:solidFill>
+            <a:ln w="25400" cap="flat">
+              <a:solidFill>
+                <a:srgbClr val="EDA100"/>
+              </a:solidFill>
+              <a:prstDash val="solid"/>
+              <a:round/>
+            </a:ln>
+            <a:effectLst/>
+          </c:spPr>
+          <c:invertIfNegative val="0"/>
+          <c:dLbls>
+            <c:numFmt formatCode="#,##0" sourceLinked="0"/>
+            <c:txPr>
+              <a:bodyPr/>
+              <a:lstStyle/>
+              <a:p>
+                <a:pPr>
+                  <a:defRPr b="0" i="0" strike="noStrike" sz="1200" u="none">
+                    <a:solidFill>
+                      <a:srgbClr val="000000"/>
+                    </a:solidFill>
+                    <a:latin typeface="Arial"/>
+                  </a:defRPr>
+                </a:pPr>
+              </a:p>
+            </c:txPr>
+            <c:showLegendKey val="0"/>
+            <c:showVal val="0"/>
+            <c:showCatName val="0"/>
+            <c:showSerName val="0"/>
+            <c:showPercent val="0"/>
+            <c:showBubbleSize val="0"/>
+            <c:showLeaderLines val="0"/>
+          </c:dLbls>
+          <c:marker>
+            <c:symbol val="circle"/>
+            <c:size val="5"/>
+            <c:spPr>
+              <a:solidFill>
+                <a:srgbClr val="EDA100"/>
+              </a:solidFill>
+              <a:ln w="9525" cap="flat">
+                <a:solidFill>
+                  <a:srgbClr val="EDA100"/>
+                </a:solidFill>
+                <a:prstDash val="solid"/>
+                <a:round/>
+              </a:ln>
+              <a:effectLst/>
+            </c:spPr>
+          </c:marker>
+          <c:cat>
+            <c:multiLvlStrRef>
+              <c:f>Sheet1!$A$2:$A$6</c:f>
+              <c:multiLvlStrCache>
+                <c:ptCount val="5"/>
+                <c:lvl>
+                  <c:pt idx="0">
+                    <c:v>8:00</c:v>
+                  </c:pt>
+                  <c:pt idx="1">
+                    <c:v>8:30</c:v>
+                  </c:pt>
+                  <c:pt idx="2">
+                    <c:v>9:00</c:v>
+                  </c:pt>
+                  <c:pt idx="3">
+                    <c:v>9:30</c:v>
+                  </c:pt>
+                  <c:pt idx="4">
+                    <c:v>10:00</c:v>
+                  </c:pt>
+                </c:lvl>
+              </c:multiLvlStrCache>
+            </c:multiLvlStrRef>
+          </c:cat>
+          <c:val>
+            <c:numRef>
+              <c:f>Sheet1!$E$2:$E$6</c:f>
+              <c:numCache>
+                <c:formatCode>General</c:formatCode>
+                <c:ptCount val="5"/>
+                <c:pt idx="0">
+                  <c:v>1.67</c:v>
+                </c:pt>
+                <c:pt idx="1">
+                  <c:v>9</c:v>
+                </c:pt>
+                <c:pt idx="2">
+                  <c:v>8</c:v>
+                </c:pt>
+                <c:pt idx="3">
+                  <c:v>5.5</c:v>
+                </c:pt>
+                <c:pt idx="4">
+                  <c:v>4.67</c:v>
                 </c:pt>
               </c:numCache>
             </c:numRef>
@@ -2545,7 +2665,7 @@
           <a:lstStyle/>
           <a:p>
             <a:pPr>
-              <a:defRPr sz="1050" b="0" i="0" u="none" strike="noStrike">
+              <a:defRPr sz="950" b="0" i="0" u="none" strike="noStrike">
                 <a:solidFill>
                   <a:srgbClr val="5C6570"/>
                 </a:solidFill>
@@ -2599,7 +2719,7 @@
           <a:lstStyle/>
           <a:p>
             <a:pPr>
-              <a:defRPr sz="1050" b="0" i="0" u="none" strike="noStrike">
+              <a:defRPr sz="950" b="0" i="0" u="none" strike="noStrike">
                 <a:solidFill>
                   <a:srgbClr val="5C6570"/>
                 </a:solidFill>
@@ -2621,24 +2741,642 @@
         <a:effectLst/>
       </c:spPr>
     </c:plotArea>
-    <c:legend>
-      <c:legendPos val="b"/>
-      <c:overlay val="0"/>
-      <c:txPr>
-        <a:bodyPr/>
-        <a:lstStyle/>
-        <a:p>
-          <a:pPr>
-            <a:defRPr sz="1100">
+    <c:plotVisOnly val="1"/>
+    <c:dispBlanksAs val="span"/>
+  </c:chart>
+  <c:spPr>
+    <a:noFill/>
+    <a:ln>
+      <a:noFill/>
+    </a:ln>
+    <a:effectLst/>
+  </c:spPr>
+  <c:externalData r:id="rId1">
+    <c:autoUpdate val="0"/>
+  </c:externalData>
+</c:chartSpace>
+</file>
+
+<file path=ppt/charts/chart6.xml><?xml version="1.0" encoding="utf-8"?>
+<c:chartSpace xmlns:c="http://schemas.openxmlformats.org/drawingml/2006/chart" xmlns:a="http://schemas.openxmlformats.org/drawingml/2006/main" xmlns:r="http://schemas.openxmlformats.org/officeDocument/2006/relationships">
+  <c:date1904 val="0"/>
+  <c:roundedCorners val="1"/>
+  <c:chart>
+    <c:autoTitleDeleted val="1"/>
+    <c:plotArea>
+      <c:layout/>
+      <c:lineChart>
+        <c:varyColors val="0"/>
+        <c:ser>
+          <c:idx val="0"/>
+          <c:order val="0"/>
+          <c:tx>
+            <c:strRef>
+              <c:f>Sheet1!$B$1</c:f>
+              <c:strCache>
+                <c:ptCount val="1"/>
+                <c:pt idx="0">
+                  <c:v>固形</c:v>
+                </c:pt>
+              </c:strCache>
+            </c:strRef>
+          </c:tx>
+          <c:spPr>
+            <a:solidFill>
+              <a:srgbClr val="2A78D6"/>
+            </a:solidFill>
+            <a:ln w="25400" cap="flat">
               <a:solidFill>
-                <a:srgbClr val="1A1A1A"/>
+                <a:srgbClr val="2A78D6"/>
               </a:solidFill>
-            </a:defRPr>
-          </a:pPr>
-          <a:endParaRPr lang="en-US"/>
-        </a:p>
-      </c:txPr>
-    </c:legend>
+              <a:prstDash val="solid"/>
+              <a:round/>
+            </a:ln>
+            <a:effectLst/>
+          </c:spPr>
+          <c:invertIfNegative val="0"/>
+          <c:dLbls>
+            <c:numFmt formatCode="#,##0" sourceLinked="0"/>
+            <c:txPr>
+              <a:bodyPr/>
+              <a:lstStyle/>
+              <a:p>
+                <a:pPr>
+                  <a:defRPr b="0" i="0" strike="noStrike" sz="1200" u="none">
+                    <a:solidFill>
+                      <a:srgbClr val="000000"/>
+                    </a:solidFill>
+                    <a:latin typeface="Arial"/>
+                  </a:defRPr>
+                </a:pPr>
+              </a:p>
+            </c:txPr>
+            <c:showLegendKey val="0"/>
+            <c:showVal val="0"/>
+            <c:showCatName val="0"/>
+            <c:showSerName val="0"/>
+            <c:showPercent val="0"/>
+            <c:showBubbleSize val="0"/>
+            <c:showLeaderLines val="0"/>
+          </c:dLbls>
+          <c:marker>
+            <c:symbol val="circle"/>
+            <c:size val="5"/>
+            <c:spPr>
+              <a:solidFill>
+                <a:srgbClr val="2A78D6"/>
+              </a:solidFill>
+              <a:ln w="9525" cap="flat">
+                <a:solidFill>
+                  <a:srgbClr val="2A78D6"/>
+                </a:solidFill>
+                <a:prstDash val="solid"/>
+                <a:round/>
+              </a:ln>
+              <a:effectLst/>
+            </c:spPr>
+          </c:marker>
+          <c:cat>
+            <c:multiLvlStrRef>
+              <c:f>Sheet1!$A$2:$A$6</c:f>
+              <c:multiLvlStrCache>
+                <c:ptCount val="5"/>
+                <c:lvl>
+                  <c:pt idx="0">
+                    <c:v>8:00</c:v>
+                  </c:pt>
+                  <c:pt idx="1">
+                    <c:v>8:30</c:v>
+                  </c:pt>
+                  <c:pt idx="2">
+                    <c:v>9:00</c:v>
+                  </c:pt>
+                  <c:pt idx="3">
+                    <c:v>9:30</c:v>
+                  </c:pt>
+                  <c:pt idx="4">
+                    <c:v>10:00</c:v>
+                  </c:pt>
+                </c:lvl>
+              </c:multiLvlStrCache>
+            </c:multiLvlStrRef>
+          </c:cat>
+          <c:val>
+            <c:numRef>
+              <c:f>Sheet1!$B$2:$B$6</c:f>
+              <c:numCache>
+                <c:formatCode>General</c:formatCode>
+                <c:ptCount val="5"/>
+                <c:pt idx="0">
+                  <c:v>7.67</c:v>
+                </c:pt>
+                <c:pt idx="1">
+                  <c:v>8</c:v>
+                </c:pt>
+                <c:pt idx="2">
+                  <c:v>7</c:v>
+                </c:pt>
+                <c:pt idx="3">
+                  <c:v>7.67</c:v>
+                </c:pt>
+                <c:pt idx="4">
+                  <c:v>7.67</c:v>
+                </c:pt>
+              </c:numCache>
+            </c:numRef>
+          </c:val>
+          <c:smooth val="0"/>
+        </c:ser>
+        <c:ser>
+          <c:idx val="1"/>
+          <c:order val="1"/>
+          <c:tx>
+            <c:strRef>
+              <c:f>Sheet1!$C$1</c:f>
+              <c:strCache>
+                <c:ptCount val="1"/>
+                <c:pt idx="0">
+                  <c:v>スムージー</c:v>
+                </c:pt>
+              </c:strCache>
+            </c:strRef>
+          </c:tx>
+          <c:spPr>
+            <a:solidFill>
+              <a:srgbClr val="EB6834"/>
+            </a:solidFill>
+            <a:ln w="25400" cap="flat">
+              <a:solidFill>
+                <a:srgbClr val="EB6834"/>
+              </a:solidFill>
+              <a:prstDash val="solid"/>
+              <a:round/>
+            </a:ln>
+            <a:effectLst/>
+          </c:spPr>
+          <c:invertIfNegative val="0"/>
+          <c:dLbls>
+            <c:numFmt formatCode="#,##0" sourceLinked="0"/>
+            <c:txPr>
+              <a:bodyPr/>
+              <a:lstStyle/>
+              <a:p>
+                <a:pPr>
+                  <a:defRPr b="0" i="0" strike="noStrike" sz="1200" u="none">
+                    <a:solidFill>
+                      <a:srgbClr val="000000"/>
+                    </a:solidFill>
+                    <a:latin typeface="Arial"/>
+                  </a:defRPr>
+                </a:pPr>
+              </a:p>
+            </c:txPr>
+            <c:showLegendKey val="0"/>
+            <c:showVal val="0"/>
+            <c:showCatName val="0"/>
+            <c:showSerName val="0"/>
+            <c:showPercent val="0"/>
+            <c:showBubbleSize val="0"/>
+            <c:showLeaderLines val="0"/>
+          </c:dLbls>
+          <c:marker>
+            <c:symbol val="circle"/>
+            <c:size val="5"/>
+            <c:spPr>
+              <a:solidFill>
+                <a:srgbClr val="EB6834"/>
+              </a:solidFill>
+              <a:ln w="9525" cap="flat">
+                <a:solidFill>
+                  <a:srgbClr val="EB6834"/>
+                </a:solidFill>
+                <a:prstDash val="solid"/>
+                <a:round/>
+              </a:ln>
+              <a:effectLst/>
+            </c:spPr>
+          </c:marker>
+          <c:cat>
+            <c:multiLvlStrRef>
+              <c:f>Sheet1!$A$2:$A$6</c:f>
+              <c:multiLvlStrCache>
+                <c:ptCount val="5"/>
+                <c:lvl>
+                  <c:pt idx="0">
+                    <c:v>8:00</c:v>
+                  </c:pt>
+                  <c:pt idx="1">
+                    <c:v>8:30</c:v>
+                  </c:pt>
+                  <c:pt idx="2">
+                    <c:v>9:00</c:v>
+                  </c:pt>
+                  <c:pt idx="3">
+                    <c:v>9:30</c:v>
+                  </c:pt>
+                  <c:pt idx="4">
+                    <c:v>10:00</c:v>
+                  </c:pt>
+                </c:lvl>
+              </c:multiLvlStrCache>
+            </c:multiLvlStrRef>
+          </c:cat>
+          <c:val>
+            <c:numRef>
+              <c:f>Sheet1!$C$2:$C$6</c:f>
+              <c:numCache>
+                <c:formatCode>General</c:formatCode>
+                <c:ptCount val="5"/>
+                <c:pt idx="0">
+                  <c:v>8.67</c:v>
+                </c:pt>
+                <c:pt idx="1">
+                  <c:v>6.33</c:v>
+                </c:pt>
+                <c:pt idx="2">
+                  <c:v>5.5</c:v>
+                </c:pt>
+                <c:pt idx="3">
+                  <c:v>7.67</c:v>
+                </c:pt>
+                <c:pt idx="4">
+                  <c:v>8.67</c:v>
+                </c:pt>
+              </c:numCache>
+            </c:numRef>
+          </c:val>
+          <c:smooth val="0"/>
+        </c:ser>
+        <c:ser>
+          <c:idx val="2"/>
+          <c:order val="2"/>
+          <c:tx>
+            <c:strRef>
+              <c:f>Sheet1!$D$1</c:f>
+              <c:strCache>
+                <c:ptCount val="1"/>
+                <c:pt idx="0">
+                  <c:v>おにぎり+スムージー</c:v>
+                </c:pt>
+              </c:strCache>
+            </c:strRef>
+          </c:tx>
+          <c:spPr>
+            <a:solidFill>
+              <a:srgbClr val="1BAF7A"/>
+            </a:solidFill>
+            <a:ln w="25400" cap="flat">
+              <a:solidFill>
+                <a:srgbClr val="1BAF7A"/>
+              </a:solidFill>
+              <a:prstDash val="solid"/>
+              <a:round/>
+            </a:ln>
+            <a:effectLst/>
+          </c:spPr>
+          <c:invertIfNegative val="0"/>
+          <c:dLbls>
+            <c:numFmt formatCode="#,##0" sourceLinked="0"/>
+            <c:txPr>
+              <a:bodyPr/>
+              <a:lstStyle/>
+              <a:p>
+                <a:pPr>
+                  <a:defRPr b="0" i="0" strike="noStrike" sz="1200" u="none">
+                    <a:solidFill>
+                      <a:srgbClr val="000000"/>
+                    </a:solidFill>
+                    <a:latin typeface="Arial"/>
+                  </a:defRPr>
+                </a:pPr>
+              </a:p>
+            </c:txPr>
+            <c:showLegendKey val="0"/>
+            <c:showVal val="0"/>
+            <c:showCatName val="0"/>
+            <c:showSerName val="0"/>
+            <c:showPercent val="0"/>
+            <c:showBubbleSize val="0"/>
+            <c:showLeaderLines val="0"/>
+          </c:dLbls>
+          <c:marker>
+            <c:symbol val="circle"/>
+            <c:size val="5"/>
+            <c:spPr>
+              <a:solidFill>
+                <a:srgbClr val="1BAF7A"/>
+              </a:solidFill>
+              <a:ln w="9525" cap="flat">
+                <a:solidFill>
+                  <a:srgbClr val="1BAF7A"/>
+                </a:solidFill>
+                <a:prstDash val="solid"/>
+                <a:round/>
+              </a:ln>
+              <a:effectLst/>
+            </c:spPr>
+          </c:marker>
+          <c:cat>
+            <c:multiLvlStrRef>
+              <c:f>Sheet1!$A$2:$A$6</c:f>
+              <c:multiLvlStrCache>
+                <c:ptCount val="5"/>
+                <c:lvl>
+                  <c:pt idx="0">
+                    <c:v>8:00</c:v>
+                  </c:pt>
+                  <c:pt idx="1">
+                    <c:v>8:30</c:v>
+                  </c:pt>
+                  <c:pt idx="2">
+                    <c:v>9:00</c:v>
+                  </c:pt>
+                  <c:pt idx="3">
+                    <c:v>9:30</c:v>
+                  </c:pt>
+                  <c:pt idx="4">
+                    <c:v>10:00</c:v>
+                  </c:pt>
+                </c:lvl>
+              </c:multiLvlStrCache>
+            </c:multiLvlStrRef>
+          </c:cat>
+          <c:val>
+            <c:numRef>
+              <c:f>Sheet1!$D$2:$D$6</c:f>
+              <c:numCache>
+                <c:formatCode>General</c:formatCode>
+                <c:ptCount val="5"/>
+                <c:pt idx="0">
+                  <c:v>7</c:v>
+                </c:pt>
+                <c:pt idx="1">
+                  <c:v>3.67</c:v>
+                </c:pt>
+                <c:pt idx="2">
+                  <c:v>5.33</c:v>
+                </c:pt>
+                <c:pt idx="3">
+                  <c:v>5.5</c:v>
+                </c:pt>
+                <c:pt idx="4">
+                  <c:v>5.67</c:v>
+                </c:pt>
+              </c:numCache>
+            </c:numRef>
+          </c:val>
+          <c:smooth val="0"/>
+        </c:ser>
+        <c:ser>
+          <c:idx val="3"/>
+          <c:order val="3"/>
+          <c:tx>
+            <c:strRef>
+              <c:f>Sheet1!$E$1</c:f>
+              <c:strCache>
+                <c:ptCount val="1"/>
+                <c:pt idx="0">
+                  <c:v>おにぎり+糖質減</c:v>
+                </c:pt>
+              </c:strCache>
+            </c:strRef>
+          </c:tx>
+          <c:spPr>
+            <a:solidFill>
+              <a:srgbClr val="EDA100"/>
+            </a:solidFill>
+            <a:ln w="25400" cap="flat">
+              <a:solidFill>
+                <a:srgbClr val="EDA100"/>
+              </a:solidFill>
+              <a:prstDash val="solid"/>
+              <a:round/>
+            </a:ln>
+            <a:effectLst/>
+          </c:spPr>
+          <c:invertIfNegative val="0"/>
+          <c:dLbls>
+            <c:numFmt formatCode="#,##0" sourceLinked="0"/>
+            <c:txPr>
+              <a:bodyPr/>
+              <a:lstStyle/>
+              <a:p>
+                <a:pPr>
+                  <a:defRPr b="0" i="0" strike="noStrike" sz="1200" u="none">
+                    <a:solidFill>
+                      <a:srgbClr val="000000"/>
+                    </a:solidFill>
+                    <a:latin typeface="Arial"/>
+                  </a:defRPr>
+                </a:pPr>
+              </a:p>
+            </c:txPr>
+            <c:showLegendKey val="0"/>
+            <c:showVal val="0"/>
+            <c:showCatName val="0"/>
+            <c:showSerName val="0"/>
+            <c:showPercent val="0"/>
+            <c:showBubbleSize val="0"/>
+            <c:showLeaderLines val="0"/>
+          </c:dLbls>
+          <c:marker>
+            <c:symbol val="circle"/>
+            <c:size val="5"/>
+            <c:spPr>
+              <a:solidFill>
+                <a:srgbClr val="EDA100"/>
+              </a:solidFill>
+              <a:ln w="9525" cap="flat">
+                <a:solidFill>
+                  <a:srgbClr val="EDA100"/>
+                </a:solidFill>
+                <a:prstDash val="solid"/>
+                <a:round/>
+              </a:ln>
+              <a:effectLst/>
+            </c:spPr>
+          </c:marker>
+          <c:cat>
+            <c:multiLvlStrRef>
+              <c:f>Sheet1!$A$2:$A$6</c:f>
+              <c:multiLvlStrCache>
+                <c:ptCount val="5"/>
+                <c:lvl>
+                  <c:pt idx="0">
+                    <c:v>8:00</c:v>
+                  </c:pt>
+                  <c:pt idx="1">
+                    <c:v>8:30</c:v>
+                  </c:pt>
+                  <c:pt idx="2">
+                    <c:v>9:00</c:v>
+                  </c:pt>
+                  <c:pt idx="3">
+                    <c:v>9:30</c:v>
+                  </c:pt>
+                  <c:pt idx="4">
+                    <c:v>10:00</c:v>
+                  </c:pt>
+                </c:lvl>
+              </c:multiLvlStrCache>
+            </c:multiLvlStrRef>
+          </c:cat>
+          <c:val>
+            <c:numRef>
+              <c:f>Sheet1!$E$2:$E$6</c:f>
+              <c:numCache>
+                <c:formatCode>General</c:formatCode>
+                <c:ptCount val="5"/>
+                <c:pt idx="0">
+                  <c:v>9</c:v>
+                </c:pt>
+                <c:pt idx="1">
+                  <c:v>3.33</c:v>
+                </c:pt>
+                <c:pt idx="2">
+                  <c:v>3</c:v>
+                </c:pt>
+                <c:pt idx="3">
+                  <c:v>4.5</c:v>
+                </c:pt>
+                <c:pt idx="4">
+                  <c:v>5.33</c:v>
+                </c:pt>
+              </c:numCache>
+            </c:numRef>
+          </c:val>
+          <c:smooth val="0"/>
+        </c:ser>
+        <c:dLbls>
+          <c:numFmt formatCode="#,##0" sourceLinked="0"/>
+          <c:txPr>
+            <a:bodyPr/>
+            <a:lstStyle/>
+            <a:p>
+              <a:pPr>
+                <a:defRPr b="0" i="0" strike="noStrike" sz="1200" u="none">
+                  <a:solidFill>
+                    <a:srgbClr val="000000"/>
+                  </a:solidFill>
+                  <a:latin typeface="Arial"/>
+                </a:defRPr>
+              </a:pPr>
+            </a:p>
+          </c:txPr>
+          <c:showLegendKey val="0"/>
+          <c:showVal val="0"/>
+          <c:showCatName val="0"/>
+          <c:showSerName val="0"/>
+          <c:showPercent val="0"/>
+          <c:showBubbleSize val="0"/>
+          <c:showLeaderLines val="0"/>
+        </c:dLbls>
+        <c:marker val="1"/>
+        <c:axId val="2094734554"/>
+        <c:axId val="2094734552"/>
+        <c:axId val="2094734556"/>
+      </c:lineChart>
+      <c:catAx>
+        <c:axId val="2094734554"/>
+        <c:scaling>
+          <c:orientation val="minMax"/>
+        </c:scaling>
+        <c:delete val="0"/>
+        <c:axPos val="b"/>
+        <c:numFmt formatCode="General" sourceLinked="1"/>
+        <c:majorTickMark val="out"/>
+        <c:minorTickMark val="none"/>
+        <c:tickLblPos val="low"/>
+        <c:spPr>
+          <a:ln w="12700" cap="flat">
+            <a:solidFill>
+              <a:srgbClr val="E3E1DB"/>
+            </a:solidFill>
+            <a:prstDash val="solid"/>
+            <a:round/>
+          </a:ln>
+        </c:spPr>
+        <c:txPr>
+          <a:bodyPr/>
+          <a:lstStyle/>
+          <a:p>
+            <a:pPr>
+              <a:defRPr sz="950" b="0" i="0" u="none" strike="noStrike">
+                <a:solidFill>
+                  <a:srgbClr val="5C6570"/>
+                </a:solidFill>
+                <a:latin typeface="Arial"/>
+              </a:defRPr>
+            </a:pPr>
+            <a:endParaRPr lang="en-US"/>
+          </a:p>
+        </c:txPr>
+        <c:crossAx val="2094734552"/>
+        <c:crosses val="autoZero"/>
+        <c:auto val="1"/>
+        <c:lblAlgn val="ctr"/>
+        <c:noMultiLvlLbl val="1"/>
+      </c:catAx>
+      <c:valAx>
+        <c:axId val="2094734552"/>
+        <c:scaling>
+          <c:orientation val="minMax"/>
+          <c:max val="10"/>
+          <c:min val="0"/>
+        </c:scaling>
+        <c:delete val="0"/>
+        <c:axPos val="l"/>
+        <c:majorGridlines>
+          <c:spPr>
+            <a:ln w="9525" cap="flat">
+              <a:solidFill>
+                <a:srgbClr val="E3E1DB"/>
+              </a:solidFill>
+              <a:prstDash val="solid"/>
+              <a:round/>
+            </a:ln>
+          </c:spPr>
+        </c:majorGridlines>
+        <c:numFmt formatCode="General" sourceLinked="0"/>
+        <c:majorTickMark val="out"/>
+        <c:minorTickMark val="none"/>
+        <c:tickLblPos val="nextTo"/>
+        <c:spPr>
+          <a:ln w="12700" cap="flat">
+            <a:solidFill>
+              <a:srgbClr val="E3E1DB"/>
+            </a:solidFill>
+            <a:prstDash val="solid"/>
+            <a:round/>
+          </a:ln>
+        </c:spPr>
+        <c:txPr>
+          <a:bodyPr/>
+          <a:lstStyle/>
+          <a:p>
+            <a:pPr>
+              <a:defRPr sz="950" b="0" i="0" u="none" strike="noStrike">
+                <a:solidFill>
+                  <a:srgbClr val="5C6570"/>
+                </a:solidFill>
+                <a:latin typeface="Arial"/>
+              </a:defRPr>
+            </a:pPr>
+            <a:endParaRPr lang="en-US"/>
+          </a:p>
+        </c:txPr>
+        <c:crossAx val="2094734554"/>
+        <c:crosses val="autoZero"/>
+        <c:crossBetween val="between"/>
+      </c:valAx>
+      <c:spPr>
+        <a:noFill/>
+        <a:ln>
+          <a:noFill/>
+        </a:ln>
+        <a:effectLst/>
+      </c:spPr>
+    </c:plotArea>
     <c:plotVisOnly val="1"/>
     <c:dispBlanksAs val="span"/>
   </c:chart>
@@ -5085,7 +5823,7 @@
                 <a:ea typeface="Calibri" pitchFamily="34" charset="-122"/>
                 <a:cs typeface="Calibri" pitchFamily="34" charset="-120"/>
               </a:rPr>
-              <a:t>おにぎり＋スムージー条件では自覚的な消化器症状（頭痛・吐き気）は軽微で忍容性は良好</a:t>
+              <a:t>頭痛・吐き気は4条件とも軽微で差がなく、血糖動態の違いが消化器症状の悪化にはつながっていない</a:t>
             </a:r>
             <a:endParaRPr lang="en-US" sz="1400" dirty="0"/>
           </a:p>
@@ -5224,7 +5962,7 @@
                 <a:ea typeface="Calibri" pitchFamily="34" charset="-122"/>
                 <a:cs typeface="Calibri" pitchFamily="34" charset="-120"/>
               </a:rPr>
-              <a:t>•  固形・スムージー・糖質減の3条件でも同形式のコンディションアンケートを取得し4条件フル比較を実現</a:t>
+              <a:t>•  満腹感・食欲の条件差は「おにぎり同時摂取による食事量の違い」であり、形態そのものの効果ではない点に留意</a:t>
             </a:r>
             <a:endParaRPr lang="en-US" sz="1250" dirty="0"/>
           </a:p>
@@ -10413,21 +11151,60 @@
                 <a:ea typeface="Cambria" pitchFamily="34" charset="-122"/>
                 <a:cs typeface="Cambria" pitchFamily="34" charset="-120"/>
               </a:rPr>
-              <a:t>自覚コンディション（おにぎり＋スムージー条件, DAY8〜10）</a:t>
+              <a:t>自覚コンディション（4条件比較）</a:t>
             </a:r>
             <a:endParaRPr lang="en-US" sz="2800" dirty="0"/>
+          </a:p>
+        </p:txBody>
+      </p:sp>
+      <p:sp>
+        <p:nvSpPr>
+          <p:cNvPr id="4" name="Text 2"/>
+          <p:cNvSpPr txBox="1"/>
+          <p:nvPr/>
+        </p:nvSpPr>
+        <p:spPr>
+          <a:xfrm>
+            <a:off x="548640" y="1600200"/>
+            <a:ext cx="6309360" cy="256032"/>
+          </a:xfrm>
+          <a:prstGeom prst="rect">
+            <a:avLst/>
+          </a:prstGeom>
+          <a:noFill/>
+          <a:ln/>
+        </p:spPr>
+        <p:txBody>
+          <a:bodyPr wrap="square" lIns="0" tIns="0" rIns="0" bIns="0" rtlCol="0" anchor="ctr"/>
+          <a:lstStyle/>
+          <a:p>
+            <a:pPr indent="0" marL="0">
+              <a:buNone/>
+            </a:pPr>
+            <a:r>
+              <a:rPr lang="en-US" sz="1250" b="1" dirty="0">
+                <a:solidFill>
+                  <a:srgbClr val="21295C"/>
+                </a:solidFill>
+                <a:latin typeface="Calibri" pitchFamily="34" charset="0"/>
+                <a:ea typeface="Calibri" pitchFamily="34" charset="-122"/>
+                <a:cs typeface="Calibri" pitchFamily="34" charset="-120"/>
+              </a:rPr>
+              <a:t>満腹感の推移 (0=空腹〜10=満腹)</a:t>
+            </a:r>
+            <a:endParaRPr lang="en-US" sz="1250" dirty="0"/>
           </a:p>
         </p:txBody>
       </p:sp>
       <p:graphicFrame>
         <p:nvGraphicFramePr>
-          <p:cNvPr id="4" name="Chart 0" descr=""/>
+          <p:cNvPr id="5" name="Chart 0" descr=""/>
           <p:cNvGraphicFramePr/>
           <p:nvPr/>
         </p:nvGraphicFramePr>
         <p:xfrm>
-          <a:off x="548640" y="1691640"/>
-          <a:ext cx="6675120" cy="4114800"/>
+          <a:off x="548640" y="1874520"/>
+          <a:ext cx="6309360" cy="1691640"/>
         </p:xfrm>
         <a:graphic xmlns:a="http://schemas.openxmlformats.org/drawingml/2006/main">
           <a:graphicData uri="http://schemas.openxmlformats.org/drawingml/2006/chart">
@@ -10437,36 +11214,14 @@
       </p:graphicFrame>
       <p:sp>
         <p:nvSpPr>
-          <p:cNvPr id="5" name="Shape 2"/>
-          <p:cNvSpPr/>
-          <p:nvPr/>
-        </p:nvSpPr>
-        <p:spPr>
-          <a:xfrm>
-            <a:off x="7909560" y="1691640"/>
-            <a:ext cx="3730752" cy="4114800"/>
-          </a:xfrm>
-          <a:prstGeom prst="roundRect">
-            <a:avLst>
-              <a:gd name="adj" fmla="val 2451"/>
-            </a:avLst>
-          </a:prstGeom>
-          <a:solidFill>
-            <a:srgbClr val="EAF7F0"/>
-          </a:solidFill>
-          <a:ln/>
-        </p:spPr>
-      </p:sp>
-      <p:sp>
-        <p:nvSpPr>
           <p:cNvPr id="6" name="Text 3"/>
           <p:cNvSpPr txBox="1"/>
           <p:nvPr/>
         </p:nvSpPr>
         <p:spPr>
           <a:xfrm>
-            <a:off x="8183880" y="1920240"/>
-            <a:ext cx="3200400" cy="365760"/>
+            <a:off x="548640" y="3703320"/>
+            <a:ext cx="6309360" cy="256032"/>
           </a:xfrm>
           <a:prstGeom prst="rect">
             <a:avLst/>
@@ -10482,30 +11237,66 @@
               <a:buNone/>
             </a:pPr>
             <a:r>
-              <a:rPr lang="en-US" sz="1400" b="1" dirty="0">
-                <a:solidFill>
-                  <a:srgbClr val="0F5C3D"/>
+              <a:rPr lang="en-US" sz="1250" b="1" dirty="0">
+                <a:solidFill>
+                  <a:srgbClr val="21295C"/>
                 </a:solidFill>
                 <a:latin typeface="Calibri" pitchFamily="34" charset="0"/>
                 <a:ea typeface="Calibri" pitchFamily="34" charset="-122"/>
                 <a:cs typeface="Calibri" pitchFamily="34" charset="-120"/>
               </a:rPr>
-              <a:t>✓ 良好な忍容性</a:t>
-            </a:r>
-            <a:endParaRPr lang="en-US" sz="1400" dirty="0"/>
-          </a:p>
-        </p:txBody>
-      </p:sp>
-      <p:sp>
-        <p:nvSpPr>
-          <p:cNvPr id="7" name="Text 4"/>
+              <a:t>食欲(摂食可能感)の推移 (0=食べられない〜10=まだ食べられる)</a:t>
+            </a:r>
+            <a:endParaRPr lang="en-US" sz="1250" dirty="0"/>
+          </a:p>
+        </p:txBody>
+      </p:sp>
+      <p:graphicFrame>
+        <p:nvGraphicFramePr>
+          <p:cNvPr id="7" name="Chart 1" descr=""/>
+          <p:cNvGraphicFramePr/>
+          <p:nvPr/>
+        </p:nvGraphicFramePr>
+        <p:xfrm>
+          <a:off x="548640" y="3977640"/>
+          <a:ext cx="6309360" cy="1691640"/>
+        </p:xfrm>
+        <a:graphic xmlns:a="http://schemas.openxmlformats.org/drawingml/2006/main">
+          <a:graphicData uri="http://schemas.openxmlformats.org/drawingml/2006/chart">
+            <c:chart xmlns:c="http://schemas.openxmlformats.org/drawingml/2006/chart" r:id="rId2"/>
+          </a:graphicData>
+        </a:graphic>
+      </p:graphicFrame>
+      <p:sp>
+        <p:nvSpPr>
+          <p:cNvPr id="8" name="Shape 4"/>
+          <p:cNvSpPr/>
+          <p:nvPr/>
+        </p:nvSpPr>
+        <p:spPr>
+          <a:xfrm>
+            <a:off x="548640" y="5870448"/>
+            <a:ext cx="146304" cy="118872"/>
+          </a:xfrm>
+          <a:prstGeom prst="rect">
+            <a:avLst/>
+          </a:prstGeom>
+          <a:solidFill>
+            <a:srgbClr val="2A78D6"/>
+          </a:solidFill>
+          <a:ln/>
+        </p:spPr>
+      </p:sp>
+      <p:sp>
+        <p:nvSpPr>
+          <p:cNvPr id="9" name="Text 5"/>
           <p:cNvSpPr txBox="1"/>
           <p:nvPr/>
         </p:nvSpPr>
         <p:spPr>
           <a:xfrm>
-            <a:off x="8183880" y="2423160"/>
-            <a:ext cx="3246120" cy="594360"/>
+            <a:off x="749808" y="5760720"/>
+            <a:ext cx="1554480" cy="274320"/>
           </a:xfrm>
           <a:prstGeom prst="rect">
             <a:avLst/>
@@ -10521,30 +11312,50 @@
               <a:buNone/>
             </a:pPr>
             <a:r>
-              <a:rPr lang="en-US" sz="1150" dirty="0">
-                <a:solidFill>
-                  <a:srgbClr val="1A1A1A"/>
+              <a:rPr lang="en-US" sz="950" dirty="0">
+                <a:solidFill>
+                  <a:srgbClr val="5C6570"/>
                 </a:solidFill>
                 <a:latin typeface="Calibri" pitchFamily="34" charset="0"/>
                 <a:ea typeface="Calibri" pitchFamily="34" charset="-122"/>
                 <a:cs typeface="Calibri" pitchFamily="34" charset="-120"/>
               </a:rPr>
-              <a:t>•  頭痛：全測定点で最小値(1)のまま変化なし</a:t>
-            </a:r>
-            <a:endParaRPr lang="en-US" sz="1150" dirty="0"/>
-          </a:p>
-        </p:txBody>
-      </p:sp>
-      <p:sp>
-        <p:nvSpPr>
-          <p:cNvPr id="8" name="Text 5"/>
+              <a:t>固形</a:t>
+            </a:r>
+            <a:endParaRPr lang="en-US" sz="950" dirty="0"/>
+          </a:p>
+        </p:txBody>
+      </p:sp>
+      <p:sp>
+        <p:nvSpPr>
+          <p:cNvPr id="10" name="Shape 6"/>
+          <p:cNvSpPr/>
+          <p:nvPr/>
+        </p:nvSpPr>
+        <p:spPr>
+          <a:xfrm>
+            <a:off x="2176272" y="5870448"/>
+            <a:ext cx="146304" cy="118872"/>
+          </a:xfrm>
+          <a:prstGeom prst="rect">
+            <a:avLst/>
+          </a:prstGeom>
+          <a:solidFill>
+            <a:srgbClr val="EB6834"/>
+          </a:solidFill>
+          <a:ln/>
+        </p:spPr>
+      </p:sp>
+      <p:sp>
+        <p:nvSpPr>
+          <p:cNvPr id="11" name="Text 7"/>
           <p:cNvSpPr txBox="1"/>
           <p:nvPr/>
         </p:nvSpPr>
         <p:spPr>
           <a:xfrm>
-            <a:off x="8183880" y="3081528"/>
-            <a:ext cx="3246120" cy="594360"/>
+            <a:off x="2377440" y="5760720"/>
+            <a:ext cx="1554480" cy="274320"/>
           </a:xfrm>
           <a:prstGeom prst="rect">
             <a:avLst/>
@@ -10560,30 +11371,50 @@
               <a:buNone/>
             </a:pPr>
             <a:r>
-              <a:rPr lang="en-US" sz="1150" dirty="0">
-                <a:solidFill>
-                  <a:srgbClr val="1A1A1A"/>
+              <a:rPr lang="en-US" sz="950" dirty="0">
+                <a:solidFill>
+                  <a:srgbClr val="5C6570"/>
                 </a:solidFill>
                 <a:latin typeface="Calibri" pitchFamily="34" charset="0"/>
                 <a:ea typeface="Calibri" pitchFamily="34" charset="-122"/>
                 <a:cs typeface="Calibri" pitchFamily="34" charset="-120"/>
               </a:rPr>
-              <a:t>•  吐き気：ほぼ1（DAY10の9:30のみ一時的に3）</a:t>
-            </a:r>
-            <a:endParaRPr lang="en-US" sz="1150" dirty="0"/>
-          </a:p>
-        </p:txBody>
-      </p:sp>
-      <p:sp>
-        <p:nvSpPr>
-          <p:cNvPr id="9" name="Text 6"/>
+              <a:t>スムージー</a:t>
+            </a:r>
+            <a:endParaRPr lang="en-US" sz="950" dirty="0"/>
+          </a:p>
+        </p:txBody>
+      </p:sp>
+      <p:sp>
+        <p:nvSpPr>
+          <p:cNvPr id="12" name="Shape 8"/>
+          <p:cNvSpPr/>
+          <p:nvPr/>
+        </p:nvSpPr>
+        <p:spPr>
+          <a:xfrm>
+            <a:off x="3803904" y="5870448"/>
+            <a:ext cx="146304" cy="118872"/>
+          </a:xfrm>
+          <a:prstGeom prst="rect">
+            <a:avLst/>
+          </a:prstGeom>
+          <a:solidFill>
+            <a:srgbClr val="1BAF7A"/>
+          </a:solidFill>
+          <a:ln/>
+        </p:spPr>
+      </p:sp>
+      <p:sp>
+        <p:nvSpPr>
+          <p:cNvPr id="13" name="Text 9"/>
           <p:cNvSpPr txBox="1"/>
           <p:nvPr/>
         </p:nvSpPr>
         <p:spPr>
           <a:xfrm>
-            <a:off x="8183880" y="3739896"/>
-            <a:ext cx="3246120" cy="594360"/>
+            <a:off x="4005072" y="5760720"/>
+            <a:ext cx="1554480" cy="274320"/>
           </a:xfrm>
           <a:prstGeom prst="rect">
             <a:avLst/>
@@ -10599,30 +11430,50 @@
               <a:buNone/>
             </a:pPr>
             <a:r>
-              <a:rPr lang="en-US" sz="1150" dirty="0">
-                <a:solidFill>
-                  <a:srgbClr val="1A1A1A"/>
+              <a:rPr lang="en-US" sz="950" dirty="0">
+                <a:solidFill>
+                  <a:srgbClr val="5C6570"/>
                 </a:solidFill>
                 <a:latin typeface="Calibri" pitchFamily="34" charset="0"/>
                 <a:ea typeface="Calibri" pitchFamily="34" charset="-122"/>
                 <a:cs typeface="Calibri" pitchFamily="34" charset="-120"/>
               </a:rPr>
-              <a:t>•  満腹感：摂取30分後にピーク(7.7/10)、10:00には3.3まで回復</a:t>
-            </a:r>
-            <a:endParaRPr lang="en-US" sz="1150" dirty="0"/>
-          </a:p>
-        </p:txBody>
-      </p:sp>
-      <p:sp>
-        <p:nvSpPr>
-          <p:cNvPr id="10" name="Text 7"/>
+              <a:t>おにぎり+スムージー</a:t>
+            </a:r>
+            <a:endParaRPr lang="en-US" sz="950" dirty="0"/>
+          </a:p>
+        </p:txBody>
+      </p:sp>
+      <p:sp>
+        <p:nvSpPr>
+          <p:cNvPr id="14" name="Shape 10"/>
+          <p:cNvSpPr/>
+          <p:nvPr/>
+        </p:nvSpPr>
+        <p:spPr>
+          <a:xfrm>
+            <a:off x="5431536" y="5870448"/>
+            <a:ext cx="146304" cy="118872"/>
+          </a:xfrm>
+          <a:prstGeom prst="rect">
+            <a:avLst/>
+          </a:prstGeom>
+          <a:solidFill>
+            <a:srgbClr val="EDA100"/>
+          </a:solidFill>
+          <a:ln/>
+        </p:spPr>
+      </p:sp>
+      <p:sp>
+        <p:nvSpPr>
+          <p:cNvPr id="15" name="Text 11"/>
           <p:cNvSpPr txBox="1"/>
           <p:nvPr/>
         </p:nvSpPr>
         <p:spPr>
           <a:xfrm>
-            <a:off x="8183880" y="4398264"/>
-            <a:ext cx="3246120" cy="594360"/>
+            <a:off x="5632704" y="5760720"/>
+            <a:ext cx="1554480" cy="274320"/>
           </a:xfrm>
           <a:prstGeom prst="rect">
             <a:avLst/>
@@ -10638,30 +11489,52 @@
               <a:buNone/>
             </a:pPr>
             <a:r>
-              <a:rPr lang="en-US" sz="1150" dirty="0">
-                <a:solidFill>
-                  <a:srgbClr val="1A1A1A"/>
+              <a:rPr lang="en-US" sz="950" dirty="0">
+                <a:solidFill>
+                  <a:srgbClr val="5C6570"/>
                 </a:solidFill>
                 <a:latin typeface="Calibri" pitchFamily="34" charset="0"/>
                 <a:ea typeface="Calibri" pitchFamily="34" charset="-122"/>
                 <a:cs typeface="Calibri" pitchFamily="34" charset="-120"/>
               </a:rPr>
-              <a:t>•  食欲：満腹感と同期して回復</a:t>
-            </a:r>
-            <a:endParaRPr lang="en-US" sz="1150" dirty="0"/>
-          </a:p>
-        </p:txBody>
-      </p:sp>
-      <p:sp>
-        <p:nvSpPr>
-          <p:cNvPr id="11" name="Text 8"/>
+              <a:t>おにぎり+糖質減</a:t>
+            </a:r>
+            <a:endParaRPr lang="en-US" sz="950" dirty="0"/>
+          </a:p>
+        </p:txBody>
+      </p:sp>
+      <p:sp>
+        <p:nvSpPr>
+          <p:cNvPr id="16" name="Shape 12"/>
+          <p:cNvSpPr/>
+          <p:nvPr/>
+        </p:nvSpPr>
+        <p:spPr>
+          <a:xfrm>
+            <a:off x="7635240" y="1600200"/>
+            <a:ext cx="4005072" cy="4434840"/>
+          </a:xfrm>
+          <a:prstGeom prst="roundRect">
+            <a:avLst>
+              <a:gd name="adj" fmla="val 2283"/>
+            </a:avLst>
+          </a:prstGeom>
+          <a:solidFill>
+            <a:srgbClr val="EAF7F0"/>
+          </a:solidFill>
+          <a:ln/>
+        </p:spPr>
+      </p:sp>
+      <p:sp>
+        <p:nvSpPr>
+          <p:cNvPr id="17" name="Text 13"/>
           <p:cNvSpPr txBox="1"/>
           <p:nvPr/>
         </p:nvSpPr>
         <p:spPr>
           <a:xfrm>
-            <a:off x="8183880" y="5056632"/>
-            <a:ext cx="3246120" cy="594360"/>
+            <a:off x="7909560" y="1828800"/>
+            <a:ext cx="3566160" cy="365760"/>
           </a:xfrm>
           <a:prstGeom prst="rect">
             <a:avLst/>
@@ -10677,30 +11550,30 @@
               <a:buNone/>
             </a:pPr>
             <a:r>
-              <a:rPr lang="en-US" sz="1150" dirty="0">
-                <a:solidFill>
-                  <a:srgbClr val="1A1A1A"/>
+              <a:rPr lang="en-US" sz="1350" b="1" dirty="0">
+                <a:solidFill>
+                  <a:srgbClr val="0F5C3D"/>
                 </a:solidFill>
                 <a:latin typeface="Calibri" pitchFamily="34" charset="0"/>
                 <a:ea typeface="Calibri" pitchFamily="34" charset="-122"/>
                 <a:cs typeface="Calibri" pitchFamily="34" charset="-120"/>
               </a:rPr>
-              <a:t>•  血糖値は高めに推移する一方、自覚的な消化器症状は軽微</a:t>
-            </a:r>
-            <a:endParaRPr lang="en-US" sz="1150" dirty="0"/>
-          </a:p>
-        </p:txBody>
-      </p:sp>
-      <p:sp>
-        <p:nvSpPr>
-          <p:cNvPr id="12" name="Text 9"/>
-          <p:cNvSpPr/>
-          <p:nvPr/>
-        </p:nvSpPr>
-        <p:spPr>
-          <a:xfrm>
-            <a:off x="548640" y="6473952"/>
-            <a:ext cx="11091672" cy="274320"/>
+              <a:t>✓ 消化器症状は4条件とも良好</a:t>
+            </a:r>
+            <a:endParaRPr lang="en-US" sz="1350" dirty="0"/>
+          </a:p>
+        </p:txBody>
+      </p:sp>
+      <p:sp>
+        <p:nvSpPr>
+          <p:cNvPr id="18" name="Text 14"/>
+          <p:cNvSpPr txBox="1"/>
+          <p:nvPr/>
+        </p:nvSpPr>
+        <p:spPr>
+          <a:xfrm>
+            <a:off x="7909560" y="2331720"/>
+            <a:ext cx="3520440" cy="868680"/>
           </a:xfrm>
           <a:prstGeom prst="rect">
             <a:avLst/>
@@ -10709,24 +11582,141 @@
           <a:ln/>
         </p:spPr>
         <p:txBody>
-          <a:bodyPr wrap="square" rtlCol="0" anchor="ctr"/>
-          <a:lstStyle/>
-          <a:p>
-            <a:pPr algn="l" indent="0" marL="0">
+          <a:bodyPr wrap="square" lIns="0" tIns="0" rIns="0" bIns="0" rtlCol="0" anchor="ctr"/>
+          <a:lstStyle/>
+          <a:p>
+            <a:pPr indent="0" marL="0">
               <a:buNone/>
             </a:pPr>
             <a:r>
-              <a:rPr lang="en-US" sz="1000" dirty="0">
-                <a:solidFill>
-                  <a:srgbClr val="5C6570"/>
+              <a:rPr lang="en-US" sz="1100" dirty="0">
+                <a:solidFill>
+                  <a:srgbClr val="1A1A1A"/>
                 </a:solidFill>
                 <a:latin typeface="Calibri" pitchFamily="34" charset="0"/>
                 <a:ea typeface="Calibri" pitchFamily="34" charset="-122"/>
                 <a:cs typeface="Calibri" pitchFamily="34" charset="-120"/>
               </a:rPr>
-              <a:t>他3条件の同形式データは提供ファイルに未収録のため、条件間の直接比較は不可。</a:t>
-            </a:r>
-            <a:endParaRPr lang="en-US" sz="1000" dirty="0"/>
+              <a:t>•  頭痛：4条件すべて全測定点で最小値(1)、変化なし</a:t>
+            </a:r>
+            <a:endParaRPr lang="en-US" sz="1100" dirty="0"/>
+          </a:p>
+        </p:txBody>
+      </p:sp>
+      <p:sp>
+        <p:nvSpPr>
+          <p:cNvPr id="19" name="Text 15"/>
+          <p:cNvSpPr txBox="1"/>
+          <p:nvPr/>
+        </p:nvSpPr>
+        <p:spPr>
+          <a:xfrm>
+            <a:off x="7909560" y="3264408"/>
+            <a:ext cx="3520440" cy="868680"/>
+          </a:xfrm>
+          <a:prstGeom prst="rect">
+            <a:avLst/>
+          </a:prstGeom>
+          <a:noFill/>
+          <a:ln/>
+        </p:spPr>
+        <p:txBody>
+          <a:bodyPr wrap="square" lIns="0" tIns="0" rIns="0" bIns="0" rtlCol="0" anchor="ctr"/>
+          <a:lstStyle/>
+          <a:p>
+            <a:pPr indent="0" marL="0">
+              <a:buNone/>
+            </a:pPr>
+            <a:r>
+              <a:rPr lang="en-US" sz="1100" dirty="0">
+                <a:solidFill>
+                  <a:srgbClr val="1A1A1A"/>
+                </a:solidFill>
+                <a:latin typeface="Calibri" pitchFamily="34" charset="0"/>
+                <a:ea typeface="Calibri" pitchFamily="34" charset="-122"/>
+                <a:cs typeface="Calibri" pitchFamily="34" charset="-120"/>
+              </a:rPr>
+              <a:t>•  吐き気：4条件すべてほぼ1（おにぎり+スムージーのDAY10 9:30のみ一時的に2）</a:t>
+            </a:r>
+            <a:endParaRPr lang="en-US" sz="1100" dirty="0"/>
+          </a:p>
+        </p:txBody>
+      </p:sp>
+      <p:sp>
+        <p:nvSpPr>
+          <p:cNvPr id="20" name="Text 16"/>
+          <p:cNvSpPr txBox="1"/>
+          <p:nvPr/>
+        </p:nvSpPr>
+        <p:spPr>
+          <a:xfrm>
+            <a:off x="7909560" y="4197096"/>
+            <a:ext cx="3520440" cy="868680"/>
+          </a:xfrm>
+          <a:prstGeom prst="rect">
+            <a:avLst/>
+          </a:prstGeom>
+          <a:noFill/>
+          <a:ln/>
+        </p:spPr>
+        <p:txBody>
+          <a:bodyPr wrap="square" lIns="0" tIns="0" rIns="0" bIns="0" rtlCol="0" anchor="ctr"/>
+          <a:lstStyle/>
+          <a:p>
+            <a:pPr indent="0" marL="0">
+              <a:buNone/>
+            </a:pPr>
+            <a:r>
+              <a:rPr lang="en-US" sz="1100" dirty="0">
+                <a:solidFill>
+                  <a:srgbClr val="1A1A1A"/>
+                </a:solidFill>
+                <a:latin typeface="Calibri" pitchFamily="34" charset="0"/>
+                <a:ea typeface="Calibri" pitchFamily="34" charset="-122"/>
+                <a:cs typeface="Calibri" pitchFamily="34" charset="-120"/>
+              </a:rPr>
+              <a:t>•  血糖値が高めに推移するおにぎり同時摂取条件でも、消化器症状は悪化していない</a:t>
+            </a:r>
+            <a:endParaRPr lang="en-US" sz="1100" dirty="0"/>
+          </a:p>
+        </p:txBody>
+      </p:sp>
+      <p:sp>
+        <p:nvSpPr>
+          <p:cNvPr id="21" name="Text 17"/>
+          <p:cNvSpPr txBox="1"/>
+          <p:nvPr/>
+        </p:nvSpPr>
+        <p:spPr>
+          <a:xfrm>
+            <a:off x="7909560" y="5129784"/>
+            <a:ext cx="3520440" cy="868680"/>
+          </a:xfrm>
+          <a:prstGeom prst="rect">
+            <a:avLst/>
+          </a:prstGeom>
+          <a:noFill/>
+          <a:ln/>
+        </p:spPr>
+        <p:txBody>
+          <a:bodyPr wrap="square" lIns="0" tIns="0" rIns="0" bIns="0" rtlCol="0" anchor="ctr"/>
+          <a:lstStyle/>
+          <a:p>
+            <a:pPr indent="0" marL="0">
+              <a:buNone/>
+            </a:pPr>
+            <a:r>
+              <a:rPr lang="en-US" sz="1100" dirty="0">
+                <a:solidFill>
+                  <a:srgbClr val="1A1A1A"/>
+                </a:solidFill>
+                <a:latin typeface="Calibri" pitchFamily="34" charset="0"/>
+                <a:ea typeface="Calibri" pitchFamily="34" charset="-122"/>
+                <a:cs typeface="Calibri" pitchFamily="34" charset="-120"/>
+              </a:rPr>
+              <a:t>•  満腹感・食欲の差は「おにぎりを同時に食べたか」による食事量の違いを反映しており、副食の形態（固形/液状）そのものの効果ではない</a:t>
+            </a:r>
+            <a:endParaRPr lang="en-US" sz="1100" dirty="0"/>
           </a:p>
         </p:txBody>
       </p:sp>

</xml_diff>